<commit_message>
DP6 KV consistency doc/slides: restate background flow (transfer vs pool -> media -> shared pool -> consistency owner), drop pre-prediction text, remove stray slide-2 button
Co-Authored-By: Claude Sonnet 5.5 <noreply@anthropic.com>
Claude-Session: https://claude.ai/code/session_01KxLPYJdxNgJF2nTMXdT3ub
</commit_message>
<xml_diff>
--- a/doc-mk/DP6/DP4-slides-draft.pptx
+++ b/doc-mk/DP6/DP4-slides-draft.pptx
@@ -515,7 +515,7 @@
           </a:p>
           <a:p>
             <a:r>
-              <a:t>이 전송을 없애는 한 방법이 CXL 공유 메모리 풀입니다. 복사 대신 load와 store로 읽고 쓰며, TraCT와 Beluga가 효과를 보고했습니다. 그런데 CXL 2.0 공유 풀은 호스트 간 캐시 일관성도, 노드 간 atomic 연산도 제공하지 않습니다. 한 노드가 쓴 값이 다른 노드에 보이지 않을 수 있고, 하드웨어 락도 쓸 수 없습니다.</a:t>
+              <a:t>전송 비용을 줄이는 방법으로는 노드 간 점대점 전송과 공유 풀이 있습니다. 두 방식의 성능 차이는 구조보다 전송 매체에서 크게 갈리므로, 매체를 CXL 공유 메모리 풀로 두는 것을 전제로 합니다. 복사 대신 load와 store로 읽고 쓰며, TraCT와 Beluga가 효과를 보고했습니다. 그런데 CXL 2.0 공유 풀은 호스트 간 캐시 일관성도, 노드 간 atomic 연산도 제공하지 않습니다. 한 노드가 쓴 값이 다른 노드에 보이지 않을 수 있고, 하드웨어 락도 쓸 수 없습니다.</a:t>
             </a:r>
           </a:p>
           <a:p>
@@ -621,11 +621,6 @@
           <a:p>
             <a:r>
               <a:t>C2는 메타데이터를 공유 메모리에 두고 모든 노드가 2단 락으로 직접 갱신합니다. TraCT가 택한 방식으로 중앙 서버가 없지만 락 매니저의 스캔 비용이 노드와 슬롯 수에 비례하고, 락을 쥔 노드가 죽으면 정체되며, clflush 누락 같은 가시성 버그 위험이 있습니다.</a:t>
-            </a:r>
-          </a:p>
-          <a:p>
-            <a:r>
-              <a:t>사전 예측은, control plane 지연이 마이크로초 규모이고 KV 이동과 prefill이 수십~수백 밀리초라서 성능 차이는 작고 trade-off는 변경 용이성, 확장 한계, 장애와 정확성에 있을 것이라는 점입니다. 시뮬레이션과 모델 체크로 이를 확인하며, 결과에 따라 이 예측이 틀릴 수도 있습니다.</a:t>
             </a:r>
           </a:p>
         </p:txBody>
@@ -4998,7 +4993,7 @@
                 </a:solidFill>
                 <a:latin typeface="맑은 고딕"/>
               </a:rPr>
-              <a:t>→ 공유 풀의 이득을 얻으려면 KV 블록과 메타데이터의 일관성을 소프트웨어가 책임져야 하며, 그 책임 구조가 설계 쟁점</a:t>
+              <a:t>→ 공유 풀을 전제로 하면 남는 문제는 KV 블록·메타데이터의 일관성이며, 그 책임을 누가 지는가가 설계 쟁점</a:t>
             </a:r>
             <a:endParaRPr lang="ko-KR" altLang="en-US" sz="1200" b="1" i="0" dirty="0">
               <a:solidFill>
@@ -5117,7 +5112,7 @@
                 </a:solidFill>
                 <a:latin typeface="맑은 고딕" panose="020B0503020000020004" pitchFamily="50" charset="-127"/>
               </a:rPr>
-              <a:t>전송을 없애는 방법이 CXL 공유 풀(복사 대신 load/store)이며 TraCT·Beluga가 효과를 보고함</a:t>
+              <a:t>전송을 줄이는 방법은 점대점 전송과 공유 풀이 있고 성능은 구조보다 전송 매체가 좌우함: CXL 공유 풀(복사 대신 load/store)을 TraCT·Beluga가 보고 [B]</a:t>
             </a:r>
             <a:endParaRPr lang="en-US" altLang="ko-KR" sz="1200" dirty="0">
               <a:solidFill>
@@ -8960,48 +8955,6 @@
       </p:sp>
       <p:sp>
         <p:nvSpPr>
-          <p:cNvPr id="102" name="실행 단추: 앞으로 또는 다음 101">
-            <a:hlinkClick r:id="" action="ppaction://noaction" highlightClick="1"/>
-          </p:cNvPr>
-          <p:cNvSpPr/>
-          <p:nvPr/>
-        </p:nvSpPr>
-        <p:spPr>
-          <a:xfrm>
-            <a:off x="537074" y="6217803"/>
-            <a:ext cx="234199" cy="234778"/>
-          </a:xfrm>
-          <a:prstGeom prst="actionButtonForwardNext">
-            <a:avLst/>
-          </a:prstGeom>
-        </p:spPr>
-        <p:style>
-          <a:lnRef idx="2">
-            <a:schemeClr val="accent1">
-              <a:shade val="50000"/>
-            </a:schemeClr>
-          </a:lnRef>
-          <a:fillRef idx="1">
-            <a:schemeClr val="accent1"/>
-          </a:fillRef>
-          <a:effectRef idx="0">
-            <a:schemeClr val="accent1"/>
-          </a:effectRef>
-          <a:fontRef idx="minor">
-            <a:schemeClr val="lt1"/>
-          </a:fontRef>
-        </p:style>
-        <p:txBody>
-          <a:bodyPr rtlCol="0" anchor="ctr"/>
-          <a:lstStyle/>
-          <a:p>
-            <a:pPr algn="ctr"/>
-            <a:endParaRPr lang="ko-KR" altLang="en-US" sz="2000"/>
-          </a:p>
-        </p:txBody>
-      </p:sp>
-      <p:sp>
-        <p:nvSpPr>
           <p:cNvPr id="139" name="Rectangle 138"/>
           <p:cNvSpPr/>
           <p:nvPr/>

</xml_diff>

<commit_message>
DP4 slide 2: draw C1 metadata server and C2 lock manager outside the CXL pool, linked via slots
Co-Authored-By: Claude Sonnet 5.5 <noreply@anthropic.com>
Claude-Session: https://claude.ai/code/session_01KxLPYJdxNgJF2nTMXdT3ub
</commit_message>
<xml_diff>
--- a/doc-mk/DP6/DP4-slides-draft.pptx
+++ b/doc-mk/DP6/DP4-slides-draft.pptx
@@ -9700,7 +9700,7 @@
         <p:spPr>
           <a:xfrm>
             <a:off x="2953512" y="2148840"/>
-            <a:ext cx="1874519" cy="1965960"/>
+            <a:ext cx="1874519" cy="1200000"/>
           </a:xfrm>
           <a:prstGeom prst="rect">
             <a:avLst/>
@@ -9923,8 +9923,8 @@
         </p:nvSpPr>
         <p:spPr>
           <a:xfrm>
-            <a:off x="3044952" y="3310128"/>
-            <a:ext cx="1691640" cy="640080"/>
+            <a:off x="3044952" y="3545000"/>
+            <a:ext cx="1691640" cy="560000"/>
           </a:xfrm>
           <a:prstGeom prst="rect">
             <a:avLst/>
@@ -9966,7 +9966,7 @@
                 <a:latin typeface="맑은 고딕"/>
                 <a:ea typeface="맑은 고딕"/>
               </a:rPr>
-              <a:t>메타데이터 서버 (단일)</a:t>
+              <a:t>«node» 메타데이터 서버 (단일)</a:t>
             </a:r>
           </a:p>
           <a:p>
@@ -10005,7 +10005,7 @@
         </p:nvSpPr>
         <p:spPr>
           <a:xfrm>
-            <a:off x="2999232" y="3364992"/>
+            <a:off x="2999232" y="3599864"/>
             <a:ext cx="91440" cy="50292"/>
           </a:xfrm>
           <a:prstGeom prst="rect">
@@ -10061,7 +10061,7 @@
         </p:nvSpPr>
         <p:spPr>
           <a:xfrm>
-            <a:off x="2999232" y="3456432"/>
+            <a:off x="2999232" y="3691304"/>
             <a:ext cx="91440" cy="50292"/>
           </a:xfrm>
           <a:prstGeom prst="rect">
@@ -11316,7 +11316,7 @@
         <p:spPr>
           <a:xfrm>
             <a:off x="8366760" y="2148840"/>
-            <a:ext cx="1874519" cy="1965960"/>
+            <a:ext cx="1874519" cy="1451160"/>
           </a:xfrm>
           <a:prstGeom prst="rect">
             <a:avLst/>
@@ -11595,8 +11595,8 @@
         </p:nvSpPr>
         <p:spPr>
           <a:xfrm>
-            <a:off x="8458200" y="3584448"/>
-            <a:ext cx="1691640" cy="420624"/>
+            <a:off x="8458200" y="3760000"/>
+            <a:ext cx="1691640" cy="360000"/>
           </a:xfrm>
           <a:prstGeom prst="rect">
             <a:avLst/>
@@ -11638,7 +11638,7 @@
                 <a:latin typeface="맑은 고딕"/>
                 <a:ea typeface="맑은 고딕"/>
               </a:rPr>
-              <a:t>락 매니저 스레드</a:t>
+              <a:t>락 매니저 스레드 (1노드)</a:t>
             </a:r>
           </a:p>
           <a:p>
@@ -11651,7 +11651,7 @@
                 <a:latin typeface="맑은 고딕"/>
                 <a:ea typeface="맑은 고딕"/>
               </a:rPr>
-              <a:t>슬롯 스캔, 1노드에 grant</a:t>
+              <a:t>슬롯 scan, 1노드에 grant</a:t>
             </a:r>
           </a:p>
         </p:txBody>
@@ -11664,7 +11664,7 @@
         </p:nvSpPr>
         <p:spPr>
           <a:xfrm>
-            <a:off x="8412480" y="3639312"/>
+            <a:off x="8412480" y="3814864"/>
             <a:ext cx="91440" cy="50292"/>
           </a:xfrm>
           <a:prstGeom prst="rect">
@@ -11720,7 +11720,7 @@
         </p:nvSpPr>
         <p:spPr>
           <a:xfrm>
-            <a:off x="8412480" y="3730752"/>
+            <a:off x="8412480" y="3906304"/>
             <a:ext cx="91440" cy="50292"/>
           </a:xfrm>
           <a:prstGeom prst="rect">
@@ -12408,6 +12408,152 @@
                 <a:ea typeface="맑은 고딕"/>
               </a:rPr>
               <a:t>풀 tier는 DP1 백엔드 인터페이스의 한 backend로 접근</a:t>
+            </a:r>
+          </a:p>
+        </p:txBody>
+      </p:sp>
+      <p:cxnSp>
+        <p:nvCxnSpPr>
+          <p:cNvPr id="204" name="C1 slot-server link"/>
+          <p:cNvCxnSpPr/>
+          <p:nvPr/>
+        </p:nvCxnSpPr>
+        <p:spPr>
+          <a:xfrm>
+            <a:off x="3890772" y="3163824"/>
+            <a:ext cx="0" cy="381176"/>
+          </a:xfrm>
+          <a:prstGeom prst="line">
+            <a:avLst/>
+          </a:prstGeom>
+          <a:ln w="15875">
+            <a:solidFill>
+              <a:srgbClr val="2F5597"/>
+            </a:solidFill>
+            <a:headEnd type="triangle"/>
+            <a:tailEnd type="triangle"/>
+          </a:ln>
+        </p:spPr>
+        <p:style>
+          <a:lnRef idx="2">
+            <a:schemeClr val="accent1"/>
+          </a:lnRef>
+          <a:fillRef idx="0">
+            <a:schemeClr val="accent1"/>
+          </a:fillRef>
+          <a:effectRef idx="1">
+            <a:schemeClr val="accent1"/>
+          </a:effectRef>
+          <a:fontRef idx="minor">
+            <a:schemeClr val="tx1"/>
+          </a:fontRef>
+        </p:style>
+      </p:cxnSp>
+      <p:sp>
+        <p:nvSpPr>
+          <p:cNvPr id="205" name="C1 link label"/>
+          <p:cNvSpPr txBox="1"/>
+          <p:nvPr/>
+        </p:nvSpPr>
+        <p:spPr>
+          <a:xfrm>
+            <a:off x="3950000" y="3355000"/>
+            <a:ext cx="880000" cy="150000"/>
+          </a:xfrm>
+          <a:prstGeom prst="rect">
+            <a:avLst/>
+          </a:prstGeom>
+          <a:noFill/>
+        </p:spPr>
+        <p:txBody>
+          <a:bodyPr wrap="square" lIns="0" tIns="0" rIns="0" bIns="0" anchor="t">
+            <a:spAutoFit/>
+          </a:bodyPr>
+          <a:lstStyle/>
+          <a:p>
+            <a:pPr algn="l"/>
+            <a:r>
+              <a:rPr sz="650" b="0" i="0">
+                <a:solidFill>
+                  <a:srgbClr val="404040"/>
+                </a:solidFill>
+                <a:latin typeface="맑은 고딕"/>
+                <a:ea typeface="맑은 고딕"/>
+              </a:rPr>
+              <a:t>슬롯 RPC</a:t>
+            </a:r>
+          </a:p>
+        </p:txBody>
+      </p:sp>
+      <p:cxnSp>
+        <p:nvCxnSpPr>
+          <p:cNvPr id="206" name="C2 lock-manager link"/>
+          <p:cNvCxnSpPr/>
+          <p:nvPr/>
+        </p:nvCxnSpPr>
+        <p:spPr>
+          <a:xfrm>
+            <a:off x="9304020" y="3511296"/>
+            <a:ext cx="0" cy="248704"/>
+          </a:xfrm>
+          <a:prstGeom prst="line">
+            <a:avLst/>
+          </a:prstGeom>
+          <a:ln w="15875">
+            <a:solidFill>
+              <a:srgbClr val="2F5597"/>
+            </a:solidFill>
+            <a:headEnd type="triangle"/>
+            <a:tailEnd type="triangle"/>
+          </a:ln>
+        </p:spPr>
+        <p:style>
+          <a:lnRef idx="2">
+            <a:schemeClr val="accent1"/>
+          </a:lnRef>
+          <a:fillRef idx="0">
+            <a:schemeClr val="accent1"/>
+          </a:fillRef>
+          <a:effectRef idx="1">
+            <a:schemeClr val="accent1"/>
+          </a:effectRef>
+          <a:fontRef idx="minor">
+            <a:schemeClr val="tx1"/>
+          </a:fontRef>
+        </p:style>
+      </p:cxnSp>
+      <p:sp>
+        <p:nvSpPr>
+          <p:cNvPr id="207" name="C2 link label"/>
+          <p:cNvSpPr txBox="1"/>
+          <p:nvPr/>
+        </p:nvSpPr>
+        <p:spPr>
+          <a:xfrm>
+            <a:off x="9360000" y="3590000"/>
+            <a:ext cx="880000" cy="150000"/>
+          </a:xfrm>
+          <a:prstGeom prst="rect">
+            <a:avLst/>
+          </a:prstGeom>
+          <a:noFill/>
+        </p:spPr>
+        <p:txBody>
+          <a:bodyPr wrap="square" lIns="0" tIns="0" rIns="0" bIns="0" anchor="t">
+            <a:spAutoFit/>
+          </a:bodyPr>
+          <a:lstStyle/>
+          <a:p>
+            <a:pPr algn="l"/>
+            <a:r>
+              <a:rPr sz="650" b="0" i="0">
+                <a:solidFill>
+                  <a:srgbClr val="404040"/>
+                </a:solidFill>
+                <a:latin typeface="맑은 고딕"/>
+                <a:ea typeface="맑은 고딕"/>
+              </a:rPr>
+              <a:t>슬롯 scan · grant</a:t>
             </a:r>
           </a:p>
         </p:txBody>

</xml_diff>